<commit_message>
Update 계산합시다 assets and add ZIP slides
Co-Authored-By: Claude Opus 4.6 (1M context) <noreply@anthropic.com>
</commit_message>
<xml_diff>
--- a/public/downloads/games/number-sum-game/rules.pptx
+++ b/public/downloads/games/number-sum-game/rules.pptx
@@ -26,16 +26,12 @@
   <p:notesSz cx="6858000" cy="9144000"/>
   <p:embeddedFontLst>
     <p:embeddedFont>
-      <p:font typeface="Jua" charset="1" panose="00000000000000000000"/>
+      <p:font typeface="무궁화 고딕" charset="1" panose="02020603020101020101"/>
       <p:regular r:id="rId22"/>
     </p:embeddedFont>
     <p:embeddedFont>
-      <p:font typeface="TDTD갬성명조" charset="1" panose="02000503000000000000"/>
+      <p:font typeface="무궁화 고딕 Bold" charset="1" panose="02020603020101020101"/>
       <p:regular r:id="rId23"/>
-    </p:embeddedFont>
-    <p:embeddedFont>
-      <p:font typeface="TDTD가온" charset="1" panose="02000503000000000000"/>
-      <p:regular r:id="rId24"/>
     </p:embeddedFont>
   </p:embeddedFontLst>
   <p:defaultTextStyle>
@@ -3103,8 +3099,8 @@
         </p:nvSpPr>
         <p:spPr>
           <a:xfrm rot="0">
-            <a:off x="1028700" y="3892867"/>
-            <a:ext cx="15555091" cy="2200275"/>
+            <a:off x="1028700" y="4178617"/>
+            <a:ext cx="15555091" cy="1914525"/>
           </a:xfrm>
           <a:prstGeom prst="rect">
             <a:avLst/>
@@ -3126,10 +3122,10 @@
                 <a:solidFill>
                   <a:srgbClr val="FFFAEF"/>
                 </a:solidFill>
-                <a:latin typeface="Jua"/>
-                <a:ea typeface="Jua"/>
-                <a:cs typeface="Jua"/>
-                <a:sym typeface="Jua"/>
+                <a:latin typeface="무궁화 고딕"/>
+                <a:ea typeface="무궁화 고딕"/>
+                <a:cs typeface="무궁화 고딕"/>
+                <a:sym typeface="무궁화 고딕"/>
               </a:rPr>
               <a:t>계산합시다</a:t>
             </a:r>
@@ -3194,8 +3190,8 @@
         </p:nvSpPr>
         <p:spPr>
           <a:xfrm rot="0">
-            <a:off x="15264803" y="9812655"/>
-            <a:ext cx="2637975" cy="474345"/>
+            <a:off x="14141856" y="9822180"/>
+            <a:ext cx="3760923" cy="464820"/>
           </a:xfrm>
           <a:prstGeom prst="rect">
             <a:avLst/>
@@ -3220,10 +3216,10 @@
                 <a:solidFill>
                   <a:srgbClr val="FFFFFF"/>
                 </a:solidFill>
-                <a:latin typeface="TDTD갬성명조"/>
-                <a:ea typeface="TDTD갬성명조"/>
-                <a:cs typeface="TDTD갬성명조"/>
-                <a:sym typeface="TDTD갬성명조"/>
+                <a:latin typeface="무궁화 고딕"/>
+                <a:ea typeface="무궁화 고딕"/>
+                <a:cs typeface="무궁화 고딕"/>
+                <a:sym typeface="무궁화 고딕"/>
               </a:rPr>
               <a:t>ⓒ 2026. Sunday Play</a:t>
             </a:r>
@@ -3270,8 +3266,8 @@
         </p:nvSpPr>
         <p:spPr>
           <a:xfrm rot="0">
-            <a:off x="1108788" y="3895725"/>
-            <a:ext cx="16070423" cy="2200275"/>
+            <a:off x="1108788" y="4214813"/>
+            <a:ext cx="16070423" cy="1847850"/>
           </a:xfrm>
           <a:prstGeom prst="rect">
             <a:avLst/>
@@ -3285,18 +3281,18 @@
           <a:p>
             <a:pPr algn="ctr">
               <a:lnSpc>
-                <a:spcPts val="15000"/>
+                <a:spcPts val="14520"/>
               </a:lnSpc>
             </a:pPr>
             <a:r>
-              <a:rPr lang="en-US" sz="12500">
+              <a:rPr lang="en-US" sz="12100">
                 <a:solidFill>
                   <a:srgbClr val="000000"/>
                 </a:solidFill>
-                <a:latin typeface="Jua"/>
-                <a:ea typeface="Jua"/>
-                <a:cs typeface="Jua"/>
-                <a:sym typeface="Jua"/>
+                <a:latin typeface="무궁화 고딕 Bold"/>
+                <a:ea typeface="무궁화 고딕 Bold"/>
+                <a:cs typeface="무궁화 고딕 Bold"/>
+                <a:sym typeface="무궁화 고딕 Bold"/>
               </a:rPr>
               <a:t>3명을 합해 20을 만드세요</a:t>
             </a:r>
@@ -3393,8 +3389,8 @@
         </p:nvSpPr>
         <p:spPr>
           <a:xfrm rot="0">
-            <a:off x="1108788" y="3895725"/>
-            <a:ext cx="16070423" cy="2200275"/>
+            <a:off x="1108788" y="4181475"/>
+            <a:ext cx="16070423" cy="1914525"/>
           </a:xfrm>
           <a:prstGeom prst="rect">
             <a:avLst/>
@@ -3416,10 +3412,10 @@
                 <a:solidFill>
                   <a:srgbClr val="000000"/>
                 </a:solidFill>
-                <a:latin typeface="Jua"/>
-                <a:ea typeface="Jua"/>
-                <a:cs typeface="Jua"/>
-                <a:sym typeface="Jua"/>
+                <a:latin typeface="무궁화 고딕 Bold"/>
+                <a:ea typeface="무궁화 고딕 Bold"/>
+                <a:cs typeface="무궁화 고딕 Bold"/>
+                <a:sym typeface="무궁화 고딕 Bold"/>
               </a:rPr>
               <a:t>4명을 합해 18을 만드세요</a:t>
             </a:r>
@@ -3516,8 +3512,8 @@
         </p:nvSpPr>
         <p:spPr>
           <a:xfrm rot="0">
-            <a:off x="1108788" y="3895725"/>
-            <a:ext cx="16070423" cy="2200275"/>
+            <a:off x="1108788" y="4181475"/>
+            <a:ext cx="16070423" cy="1914525"/>
           </a:xfrm>
           <a:prstGeom prst="rect">
             <a:avLst/>
@@ -3539,10 +3535,10 @@
                 <a:solidFill>
                   <a:srgbClr val="000000"/>
                 </a:solidFill>
-                <a:latin typeface="Jua"/>
-                <a:ea typeface="Jua"/>
-                <a:cs typeface="Jua"/>
-                <a:sym typeface="Jua"/>
+                <a:latin typeface="무궁화 고딕 Bold"/>
+                <a:ea typeface="무궁화 고딕 Bold"/>
+                <a:cs typeface="무궁화 고딕 Bold"/>
+                <a:sym typeface="무궁화 고딕 Bold"/>
               </a:rPr>
               <a:t>2명을 합해 3을 만드세요</a:t>
             </a:r>
@@ -3639,8 +3635,8 @@
         </p:nvSpPr>
         <p:spPr>
           <a:xfrm rot="0">
-            <a:off x="1108788" y="3895725"/>
-            <a:ext cx="16070423" cy="2200275"/>
+            <a:off x="1108788" y="4214813"/>
+            <a:ext cx="16070423" cy="1847850"/>
           </a:xfrm>
           <a:prstGeom prst="rect">
             <a:avLst/>
@@ -3654,18 +3650,18 @@
           <a:p>
             <a:pPr algn="ctr">
               <a:lnSpc>
-                <a:spcPts val="15000"/>
+                <a:spcPts val="14520"/>
               </a:lnSpc>
             </a:pPr>
             <a:r>
-              <a:rPr lang="en-US" sz="12500">
+              <a:rPr lang="en-US" sz="12100">
                 <a:solidFill>
                   <a:srgbClr val="000000"/>
                 </a:solidFill>
-                <a:latin typeface="Jua"/>
-                <a:ea typeface="Jua"/>
-                <a:cs typeface="Jua"/>
-                <a:sym typeface="Jua"/>
+                <a:latin typeface="무궁화 고딕 Bold"/>
+                <a:ea typeface="무궁화 고딕 Bold"/>
+                <a:cs typeface="무궁화 고딕 Bold"/>
+                <a:sym typeface="무궁화 고딕 Bold"/>
               </a:rPr>
               <a:t>4명을 합해 25를 만드세요</a:t>
             </a:r>
@@ -3762,8 +3758,8 @@
         </p:nvSpPr>
         <p:spPr>
           <a:xfrm rot="0">
-            <a:off x="1108788" y="3895725"/>
-            <a:ext cx="16070423" cy="2200275"/>
+            <a:off x="1108788" y="4219575"/>
+            <a:ext cx="16070423" cy="1838325"/>
           </a:xfrm>
           <a:prstGeom prst="rect">
             <a:avLst/>
@@ -3777,18 +3773,18 @@
           <a:p>
             <a:pPr algn="ctr">
               <a:lnSpc>
-                <a:spcPts val="15000"/>
+                <a:spcPts val="14400"/>
               </a:lnSpc>
             </a:pPr>
             <a:r>
-              <a:rPr lang="en-US" sz="12500">
+              <a:rPr lang="en-US" sz="12000">
                 <a:solidFill>
                   <a:srgbClr val="000000"/>
                 </a:solidFill>
-                <a:latin typeface="Jua"/>
-                <a:ea typeface="Jua"/>
-                <a:cs typeface="Jua"/>
-                <a:sym typeface="Jua"/>
+                <a:latin typeface="무궁화 고딕 Bold"/>
+                <a:ea typeface="무궁화 고딕 Bold"/>
+                <a:cs typeface="무궁화 고딕 Bold"/>
+                <a:sym typeface="무궁화 고딕 Bold"/>
               </a:rPr>
               <a:t>5명을 합해 30을 만드세요</a:t>
             </a:r>
@@ -3885,8 +3881,8 @@
         </p:nvSpPr>
         <p:spPr>
           <a:xfrm rot="0">
-            <a:off x="1108788" y="3895725"/>
-            <a:ext cx="16070423" cy="2200275"/>
+            <a:off x="1108788" y="4219575"/>
+            <a:ext cx="16070423" cy="1838325"/>
           </a:xfrm>
           <a:prstGeom prst="rect">
             <a:avLst/>
@@ -3900,18 +3896,18 @@
           <a:p>
             <a:pPr algn="ctr">
               <a:lnSpc>
-                <a:spcPts val="15000"/>
+                <a:spcPts val="14400"/>
               </a:lnSpc>
             </a:pPr>
             <a:r>
-              <a:rPr lang="en-US" sz="12500">
+              <a:rPr lang="en-US" sz="12000">
                 <a:solidFill>
                   <a:srgbClr val="000000"/>
                 </a:solidFill>
-                <a:latin typeface="Jua"/>
-                <a:ea typeface="Jua"/>
-                <a:cs typeface="Jua"/>
-                <a:sym typeface="Jua"/>
+                <a:latin typeface="무궁화 고딕 Bold"/>
+                <a:ea typeface="무궁화 고딕 Bold"/>
+                <a:cs typeface="무궁화 고딕 Bold"/>
+                <a:sym typeface="무궁화 고딕 Bold"/>
               </a:rPr>
               <a:t>9명을 합해 45를 만드세요</a:t>
             </a:r>
@@ -4033,8 +4029,8 @@
         </p:nvSpPr>
         <p:spPr>
           <a:xfrm rot="0">
-            <a:off x="4421807" y="3895725"/>
-            <a:ext cx="9444385" cy="2200275"/>
+            <a:off x="4421807" y="4181475"/>
+            <a:ext cx="9444385" cy="1914525"/>
           </a:xfrm>
           <a:prstGeom prst="rect">
             <a:avLst/>
@@ -4056,10 +4052,10 @@
                 <a:solidFill>
                   <a:srgbClr val="000000"/>
                 </a:solidFill>
-                <a:latin typeface="Jua"/>
-                <a:ea typeface="Jua"/>
-                <a:cs typeface="Jua"/>
-                <a:sym typeface="Jua"/>
+                <a:latin typeface="무궁화 고딕"/>
+                <a:ea typeface="무궁화 고딕"/>
+                <a:cs typeface="무궁화 고딕"/>
+                <a:sym typeface="무궁화 고딕"/>
               </a:rPr>
               <a:t>감사합니다!</a:t>
             </a:r>
@@ -4258,8 +4254,8 @@
         </p:nvSpPr>
         <p:spPr>
           <a:xfrm rot="0">
-            <a:off x="11392761" y="600705"/>
-            <a:ext cx="5362043" cy="1600200"/>
+            <a:off x="11392761" y="819780"/>
+            <a:ext cx="5362043" cy="1381125"/>
           </a:xfrm>
           <a:prstGeom prst="rect">
             <a:avLst/>
@@ -4281,10 +4277,10 @@
                 <a:solidFill>
                   <a:srgbClr val="FFFAEF"/>
                 </a:solidFill>
-                <a:latin typeface="Jua"/>
-                <a:ea typeface="Jua"/>
-                <a:cs typeface="Jua"/>
-                <a:sym typeface="Jua"/>
+                <a:latin typeface="무궁화 고딕"/>
+                <a:ea typeface="무궁화 고딕"/>
+                <a:cs typeface="무궁화 고딕"/>
+                <a:sym typeface="무궁화 고딕"/>
               </a:rPr>
               <a:t>규칙</a:t>
             </a:r>
@@ -4300,9 +4296,9 @@
         <p:grpSpPr>
           <a:xfrm rot="0">
             <a:off x="557737" y="564396"/>
-            <a:ext cx="10108960" cy="3115126"/>
+            <a:ext cx="10108960" cy="2845676"/>
             <a:chOff x="0" y="0"/>
-            <a:chExt cx="13478613" cy="4153501"/>
+            <a:chExt cx="13478613" cy="3794235"/>
           </a:xfrm>
         </p:grpSpPr>
         <p:sp>
@@ -4313,8 +4309,8 @@
           </p:nvSpPr>
           <p:spPr>
             <a:xfrm rot="0">
-              <a:off x="0" y="1359653"/>
-              <a:ext cx="13478613" cy="2793849"/>
+              <a:off x="0" y="1350544"/>
+              <a:ext cx="13478613" cy="2443692"/>
             </a:xfrm>
             <a:prstGeom prst="rect">
               <a:avLst/>
@@ -4328,30 +4324,30 @@
             <a:p>
               <a:pPr algn="l">
                 <a:lnSpc>
-                  <a:spcPts val="5670"/>
+                  <a:spcPts val="4900"/>
                 </a:lnSpc>
               </a:pPr>
               <a:r>
-                <a:rPr lang="en-US" sz="4050">
+                <a:rPr lang="en-US" sz="3500">
                   <a:solidFill>
                     <a:srgbClr val="FFFAEF"/>
                   </a:solidFill>
-                  <a:latin typeface="TDTD가온"/>
-                  <a:ea typeface="TDTD가온"/>
-                  <a:cs typeface="TDTD가온"/>
-                  <a:sym typeface="TDTD가온"/>
+                  <a:latin typeface="무궁화 고딕"/>
+                  <a:ea typeface="무궁화 고딕"/>
+                  <a:cs typeface="무궁화 고딕"/>
+                  <a:sym typeface="무궁화 고딕"/>
                 </a:rPr>
-                <a:t> 숫자</a:t>
+                <a:t>숫자</a:t>
               </a:r>
               <a:r>
-                <a:rPr lang="en-US" sz="4050">
+                <a:rPr lang="en-US" sz="3500">
                   <a:solidFill>
                     <a:srgbClr val="FFFAEF"/>
                   </a:solidFill>
-                  <a:latin typeface="TDTD가온"/>
-                  <a:ea typeface="TDTD가온"/>
-                  <a:cs typeface="TDTD가온"/>
-                  <a:sym typeface="TDTD가온"/>
+                  <a:latin typeface="무궁화 고딕"/>
+                  <a:ea typeface="무궁화 고딕"/>
+                  <a:cs typeface="무궁화 고딕"/>
+                  <a:sym typeface="무궁화 고딕"/>
                 </a:rPr>
                 <a:t> 카드를 1장씩 받고, 팀별로 원형으로 둘러앉습니다.                                                                    </a:t>
               </a:r>
@@ -4359,26 +4355,26 @@
             <a:p>
               <a:pPr algn="l">
                 <a:lnSpc>
-                  <a:spcPts val="5670"/>
+                  <a:spcPts val="4900"/>
                 </a:lnSpc>
               </a:pPr>
               <a:r>
-                <a:rPr lang="en-US" sz="4050">
+                <a:rPr lang="en-US" sz="3500">
                   <a:solidFill>
                     <a:srgbClr val="FFFAEF"/>
                   </a:solidFill>
-                  <a:latin typeface="TDTD가온"/>
-                  <a:ea typeface="TDTD가온"/>
-                  <a:cs typeface="TDTD가온"/>
-                  <a:sym typeface="TDTD가온"/>
+                  <a:latin typeface="무궁화 고딕"/>
+                  <a:ea typeface="무궁화 고딕"/>
+                  <a:cs typeface="무궁화 고딕"/>
+                  <a:sym typeface="무궁화 고딕"/>
                 </a:rPr>
-                <a:t> (자기 숫자를 확인하고 기억하세요!)   </a:t>
+                <a:t>(자기 숫자를 확인하고 기억하세요!)   </a:t>
               </a:r>
             </a:p>
             <a:p>
               <a:pPr algn="l">
                 <a:lnSpc>
-                  <a:spcPts val="5670"/>
+                  <a:spcPts val="4900"/>
                 </a:lnSpc>
               </a:pPr>
             </a:p>
@@ -4392,8 +4388,8 @@
           </p:nvSpPr>
           <p:spPr>
             <a:xfrm rot="0">
-              <a:off x="0" y="-152400"/>
-              <a:ext cx="10684245" cy="1065427"/>
+              <a:off x="0" y="-47625"/>
+              <a:ext cx="10684245" cy="961068"/>
             </a:xfrm>
             <a:prstGeom prst="rect">
               <a:avLst/>
@@ -4415,10 +4411,10 @@
                   <a:solidFill>
                     <a:srgbClr val="FFFAEF"/>
                   </a:solidFill>
-                  <a:latin typeface="Jua"/>
-                  <a:ea typeface="Jua"/>
-                  <a:cs typeface="Jua"/>
-                  <a:sym typeface="Jua"/>
+                  <a:latin typeface="무궁화 고딕 Bold"/>
+                  <a:ea typeface="무궁화 고딕 Bold"/>
+                  <a:cs typeface="무궁화 고딕 Bold"/>
+                  <a:sym typeface="무궁화 고딕 Bold"/>
                 </a:rPr>
                 <a:t>STEP 1.</a:t>
               </a:r>
@@ -4435,9 +4431,9 @@
         <p:grpSpPr>
           <a:xfrm rot="0">
             <a:off x="10899644" y="7549671"/>
-            <a:ext cx="7913775" cy="3076481"/>
+            <a:ext cx="7913775" cy="2212880"/>
             <a:chOff x="0" y="0"/>
-            <a:chExt cx="10551700" cy="4101974"/>
+            <a:chExt cx="10551700" cy="2950507"/>
           </a:xfrm>
         </p:grpSpPr>
         <p:sp>
@@ -4448,8 +4444,8 @@
           </p:nvSpPr>
           <p:spPr>
             <a:xfrm rot="0">
-              <a:off x="0" y="1332315"/>
-              <a:ext cx="10551700" cy="2769659"/>
+              <a:off x="0" y="1351365"/>
+              <a:ext cx="10551700" cy="1599142"/>
             </a:xfrm>
             <a:prstGeom prst="rect">
               <a:avLst/>
@@ -4463,30 +4459,18 @@
             <a:p>
               <a:pPr algn="l">
                 <a:lnSpc>
-                  <a:spcPts val="5599"/>
+                  <a:spcPts val="4899"/>
                 </a:lnSpc>
               </a:pPr>
               <a:r>
-                <a:rPr lang="en-US" sz="3999">
+                <a:rPr lang="en-US" sz="3499">
                   <a:solidFill>
                     <a:srgbClr val="FFFAEF"/>
                   </a:solidFill>
-                  <a:latin typeface="TDTD가온"/>
-                  <a:ea typeface="TDTD가온"/>
-                  <a:cs typeface="TDTD가온"/>
-                  <a:sym typeface="TDTD가온"/>
-                </a:rPr>
-                <a:t> </a:t>
-              </a:r>
-              <a:r>
-                <a:rPr lang="en-US" sz="3999">
-                  <a:solidFill>
-                    <a:srgbClr val="FFFAEF"/>
-                  </a:solidFill>
-                  <a:latin typeface="TDTD가온"/>
-                  <a:ea typeface="TDTD가온"/>
-                  <a:cs typeface="TDTD가온"/>
-                  <a:sym typeface="TDTD가온"/>
+                  <a:latin typeface="무궁화 고딕"/>
+                  <a:ea typeface="무궁화 고딕"/>
+                  <a:cs typeface="무궁화 고딕"/>
+                  <a:sym typeface="무궁화 고딕"/>
                 </a:rPr>
                 <a:t>카드를 높이 들어 진행자에게 확인!                                                                              </a:t>
               </a:r>
@@ -4494,28 +4478,21 @@
             <a:p>
               <a:pPr algn="l">
                 <a:lnSpc>
-                  <a:spcPts val="5599"/>
+                  <a:spcPts val="4899"/>
                 </a:lnSpc>
               </a:pPr>
               <a:r>
-                <a:rPr lang="en-US" sz="3999">
+                <a:rPr lang="en-US" sz="3499">
                   <a:solidFill>
                     <a:srgbClr val="FFFAEF"/>
                   </a:solidFill>
-                  <a:latin typeface="TDTD가온"/>
-                  <a:ea typeface="TDTD가온"/>
-                  <a:cs typeface="TDTD가온"/>
-                  <a:sym typeface="TDTD가온"/>
+                  <a:latin typeface="무궁화 고딕"/>
+                  <a:ea typeface="무궁화 고딕"/>
+                  <a:cs typeface="무궁화 고딕"/>
+                  <a:sym typeface="무궁화 고딕"/>
                 </a:rPr>
-                <a:t> 가장 먼저 정확히 맞춘 팀이 득점!  </a:t>
+                <a:t>가장 먼저 정확히 맞춘 팀이 득점!  </a:t>
               </a:r>
-            </a:p>
-            <a:p>
-              <a:pPr algn="l">
-                <a:lnSpc>
-                  <a:spcPts val="5599"/>
-                </a:lnSpc>
-              </a:pPr>
             </a:p>
           </p:txBody>
         </p:sp>
@@ -4527,8 +4504,8 @@
           </p:nvSpPr>
           <p:spPr>
             <a:xfrm rot="0">
-              <a:off x="0" y="-161925"/>
-              <a:ext cx="10551700" cy="1063625"/>
+              <a:off x="0" y="-47625"/>
+              <a:ext cx="10551700" cy="949325"/>
             </a:xfrm>
             <a:prstGeom prst="rect">
               <a:avLst/>
@@ -4550,10 +4527,10 @@
                   <a:solidFill>
                     <a:srgbClr val="FFFAEF"/>
                   </a:solidFill>
-                  <a:latin typeface="Jua"/>
-                  <a:ea typeface="Jua"/>
-                  <a:cs typeface="Jua"/>
-                  <a:sym typeface="Jua"/>
+                  <a:latin typeface="무궁화 고딕 Bold"/>
+                  <a:ea typeface="무궁화 고딕 Bold"/>
+                  <a:cs typeface="무궁화 고딕 Bold"/>
+                  <a:sym typeface="무궁화 고딕 Bold"/>
                 </a:rPr>
                 <a:t>STEP 3.</a:t>
               </a:r>
@@ -4570,9 +4547,9 @@
         <p:grpSpPr>
           <a:xfrm rot="0">
             <a:off x="5187112" y="3768340"/>
-            <a:ext cx="7913775" cy="3781331"/>
+            <a:ext cx="7913775" cy="3451130"/>
             <a:chOff x="0" y="0"/>
-            <a:chExt cx="10551700" cy="5041774"/>
+            <a:chExt cx="10551700" cy="4601507"/>
           </a:xfrm>
         </p:grpSpPr>
         <p:sp>
@@ -4583,8 +4560,8 @@
           </p:nvSpPr>
           <p:spPr>
             <a:xfrm rot="0">
-              <a:off x="0" y="1332315"/>
-              <a:ext cx="10551700" cy="3709459"/>
+              <a:off x="0" y="1351365"/>
+              <a:ext cx="10551700" cy="3250142"/>
             </a:xfrm>
             <a:prstGeom prst="rect">
               <a:avLst/>
@@ -4598,30 +4575,30 @@
             <a:p>
               <a:pPr algn="l">
                 <a:lnSpc>
-                  <a:spcPts val="5599"/>
+                  <a:spcPts val="4899"/>
                 </a:lnSpc>
               </a:pPr>
               <a:r>
-                <a:rPr lang="en-US" sz="3999">
+                <a:rPr lang="en-US" sz="3499">
                   <a:solidFill>
                     <a:srgbClr val="FFFAEF"/>
                   </a:solidFill>
-                  <a:latin typeface="TDTD가온"/>
-                  <a:ea typeface="TDTD가온"/>
-                  <a:cs typeface="TDTD가온"/>
-                  <a:sym typeface="TDTD가온"/>
+                  <a:latin typeface="무궁화 고딕"/>
+                  <a:ea typeface="무궁화 고딕"/>
+                  <a:cs typeface="무궁화 고딕"/>
+                  <a:sym typeface="무궁화 고딕"/>
                 </a:rPr>
                 <a:t>진행자가 인원수와 목표 숫자</a:t>
               </a:r>
               <a:r>
-                <a:rPr lang="en-US" sz="3999">
+                <a:rPr lang="en-US" sz="3499">
                   <a:solidFill>
                     <a:srgbClr val="FFFAEF"/>
                   </a:solidFill>
-                  <a:latin typeface="TDTD가온"/>
-                  <a:ea typeface="TDTD가온"/>
-                  <a:cs typeface="TDTD가온"/>
-                  <a:sym typeface="TDTD가온"/>
+                  <a:latin typeface="무궁화 고딕"/>
+                  <a:ea typeface="무궁화 고딕"/>
+                  <a:cs typeface="무궁화 고딕"/>
+                  <a:sym typeface="무궁화 고딕"/>
                 </a:rPr>
                 <a:t>를 부릅니다.                                                                           </a:t>
               </a:r>
@@ -4629,45 +4606,45 @@
             <a:p>
               <a:pPr algn="l">
                 <a:lnSpc>
-                  <a:spcPts val="5599"/>
+                  <a:spcPts val="4899"/>
                 </a:lnSpc>
               </a:pPr>
               <a:r>
-                <a:rPr lang="en-US" sz="3999">
+                <a:rPr lang="en-US" sz="3499">
                   <a:solidFill>
                     <a:srgbClr val="FFFAEF"/>
                   </a:solidFill>
-                  <a:latin typeface="TDTD가온"/>
-                  <a:ea typeface="TDTD가온"/>
-                  <a:cs typeface="TDTD가온"/>
-                  <a:sym typeface="TDTD가온"/>
+                  <a:latin typeface="무궁화 고딕"/>
+                  <a:ea typeface="무궁화 고딕"/>
+                  <a:cs typeface="무궁화 고딕"/>
+                  <a:sym typeface="무궁화 고딕"/>
                 </a:rPr>
-                <a:t> 예: "3명이서 합쳐서 15!"                  </a:t>
+                <a:t>예: "3명이서 합쳐서 15!"                  </a:t>
               </a:r>
             </a:p>
             <a:p>
               <a:pPr algn="l">
                 <a:lnSpc>
-                  <a:spcPts val="5599"/>
+                  <a:spcPts val="4899"/>
                 </a:lnSpc>
               </a:pPr>
               <a:r>
-                <a:rPr lang="en-US" sz="3999">
+                <a:rPr lang="en-US" sz="3499">
                   <a:solidFill>
                     <a:srgbClr val="FFFAEF"/>
                   </a:solidFill>
-                  <a:latin typeface="TDTD가온"/>
-                  <a:ea typeface="TDTD가온"/>
-                  <a:cs typeface="TDTD가온"/>
-                  <a:sym typeface="TDTD가온"/>
+                  <a:latin typeface="무궁화 고딕"/>
+                  <a:ea typeface="무궁화 고딕"/>
+                  <a:cs typeface="무궁화 고딕"/>
+                  <a:sym typeface="무궁화 고딕"/>
                 </a:rPr>
-                <a:t> → 해당하는 사람들이 원 중앙으로 모입니다.</a:t>
+                <a:t>→ 해당하는 사람들이 원 중앙으로 모입니다.</a:t>
               </a:r>
             </a:p>
             <a:p>
               <a:pPr algn="l">
                 <a:lnSpc>
-                  <a:spcPts val="5599"/>
+                  <a:spcPts val="4899"/>
                 </a:lnSpc>
               </a:pPr>
             </a:p>
@@ -4681,8 +4658,8 @@
           </p:nvSpPr>
           <p:spPr>
             <a:xfrm rot="0">
-              <a:off x="0" y="-161925"/>
-              <a:ext cx="10551700" cy="1063625"/>
+              <a:off x="0" y="-47625"/>
+              <a:ext cx="10551700" cy="949325"/>
             </a:xfrm>
             <a:prstGeom prst="rect">
               <a:avLst/>
@@ -4704,10 +4681,10 @@
                   <a:solidFill>
                     <a:srgbClr val="FFFAEF"/>
                   </a:solidFill>
-                  <a:latin typeface="Jua"/>
-                  <a:ea typeface="Jua"/>
-                  <a:cs typeface="Jua"/>
-                  <a:sym typeface="Jua"/>
+                  <a:latin typeface="무궁화 고딕 Bold"/>
+                  <a:ea typeface="무궁화 고딕 Bold"/>
+                  <a:cs typeface="무궁화 고딕 Bold"/>
+                  <a:sym typeface="무궁화 고딕 Bold"/>
                 </a:rPr>
                 <a:t>STEP 2.</a:t>
               </a:r>
@@ -4755,8 +4732,8 @@
         </p:nvSpPr>
         <p:spPr>
           <a:xfrm rot="0">
-            <a:off x="3238925" y="4092795"/>
-            <a:ext cx="11810151" cy="2200275"/>
+            <a:off x="3238925" y="4378545"/>
+            <a:ext cx="11810151" cy="1914525"/>
           </a:xfrm>
           <a:prstGeom prst="rect">
             <a:avLst/>
@@ -4778,10 +4755,10 @@
                 <a:solidFill>
                   <a:srgbClr val="000000"/>
                 </a:solidFill>
-                <a:latin typeface="Jua"/>
-                <a:ea typeface="Jua"/>
-                <a:cs typeface="Jua"/>
-                <a:sym typeface="Jua"/>
+                <a:latin typeface="무궁화 고딕"/>
+                <a:ea typeface="무궁화 고딕"/>
+                <a:cs typeface="무궁화 고딕"/>
+                <a:sym typeface="무궁화 고딕"/>
               </a:rPr>
               <a:t>팀을 나눠주세요!</a:t>
             </a:r>
@@ -4878,8 +4855,8 @@
         </p:nvSpPr>
         <p:spPr>
           <a:xfrm rot="0">
-            <a:off x="1028700" y="3892867"/>
-            <a:ext cx="15555091" cy="2200275"/>
+            <a:off x="1028700" y="4178617"/>
+            <a:ext cx="15555091" cy="1914525"/>
           </a:xfrm>
           <a:prstGeom prst="rect">
             <a:avLst/>
@@ -4901,10 +4878,10 @@
                 <a:solidFill>
                   <a:srgbClr val="FFFAEF"/>
                 </a:solidFill>
-                <a:latin typeface="Jua"/>
-                <a:ea typeface="Jua"/>
-                <a:cs typeface="Jua"/>
-                <a:sym typeface="Jua"/>
+                <a:latin typeface="무궁화 고딕"/>
+                <a:ea typeface="무궁화 고딕"/>
+                <a:cs typeface="무궁화 고딕"/>
+                <a:sym typeface="무궁화 고딕"/>
               </a:rPr>
               <a:t>계산합시다</a:t>
             </a:r>
@@ -4969,8 +4946,8 @@
         </p:nvSpPr>
         <p:spPr>
           <a:xfrm rot="0">
-            <a:off x="15264803" y="9812655"/>
-            <a:ext cx="2637975" cy="474345"/>
+            <a:off x="14141856" y="9822180"/>
+            <a:ext cx="3760923" cy="464820"/>
           </a:xfrm>
           <a:prstGeom prst="rect">
             <a:avLst/>
@@ -4995,10 +4972,10 @@
                 <a:solidFill>
                   <a:srgbClr val="FFFFFF"/>
                 </a:solidFill>
-                <a:latin typeface="TDTD갬성명조"/>
-                <a:ea typeface="TDTD갬성명조"/>
-                <a:cs typeface="TDTD갬성명조"/>
-                <a:sym typeface="TDTD갬성명조"/>
+                <a:latin typeface="무궁화 고딕"/>
+                <a:ea typeface="무궁화 고딕"/>
+                <a:cs typeface="무궁화 고딕"/>
+                <a:sym typeface="무궁화 고딕"/>
               </a:rPr>
               <a:t>ⓒ 2026. Sunday Play</a:t>
             </a:r>
@@ -5045,8 +5022,8 @@
         </p:nvSpPr>
         <p:spPr>
           <a:xfrm rot="0">
-            <a:off x="1108788" y="3895725"/>
-            <a:ext cx="16070423" cy="2200275"/>
+            <a:off x="1108788" y="4181475"/>
+            <a:ext cx="16070423" cy="1914525"/>
           </a:xfrm>
           <a:prstGeom prst="rect">
             <a:avLst/>
@@ -5068,10 +5045,10 @@
                 <a:solidFill>
                   <a:srgbClr val="000000"/>
                 </a:solidFill>
-                <a:latin typeface="Jua"/>
-                <a:ea typeface="Jua"/>
-                <a:cs typeface="Jua"/>
-                <a:sym typeface="Jua"/>
+                <a:latin typeface="무궁화 고딕 Bold"/>
+                <a:ea typeface="무궁화 고딕 Bold"/>
+                <a:cs typeface="무궁화 고딕 Bold"/>
+                <a:sym typeface="무궁화 고딕 Bold"/>
               </a:rPr>
               <a:t>2명을 합해 7을 만드세요</a:t>
             </a:r>
@@ -5168,8 +5145,8 @@
         </p:nvSpPr>
         <p:spPr>
           <a:xfrm rot="0">
-            <a:off x="1108788" y="3895725"/>
-            <a:ext cx="16070423" cy="2200275"/>
+            <a:off x="1108788" y="4191000"/>
+            <a:ext cx="16070423" cy="1895475"/>
           </a:xfrm>
           <a:prstGeom prst="rect">
             <a:avLst/>
@@ -5183,18 +5160,18 @@
           <a:p>
             <a:pPr algn="ctr">
               <a:lnSpc>
-                <a:spcPts val="15000"/>
+                <a:spcPts val="14880"/>
               </a:lnSpc>
             </a:pPr>
             <a:r>
-              <a:rPr lang="en-US" sz="12500">
+              <a:rPr lang="en-US" sz="12400">
                 <a:solidFill>
                   <a:srgbClr val="000000"/>
                 </a:solidFill>
-                <a:latin typeface="Jua"/>
-                <a:ea typeface="Jua"/>
-                <a:cs typeface="Jua"/>
-                <a:sym typeface="Jua"/>
+                <a:latin typeface="무궁화 고딕 Bold"/>
+                <a:ea typeface="무궁화 고딕 Bold"/>
+                <a:cs typeface="무궁화 고딕 Bold"/>
+                <a:sym typeface="무궁화 고딕 Bold"/>
               </a:rPr>
               <a:t>2명을 합해 10을 만드세요</a:t>
             </a:r>
@@ -5291,8 +5268,8 @@
         </p:nvSpPr>
         <p:spPr>
           <a:xfrm rot="0">
-            <a:off x="1108788" y="3895725"/>
-            <a:ext cx="16070423" cy="2200275"/>
+            <a:off x="1108788" y="4191000"/>
+            <a:ext cx="16070423" cy="1895475"/>
           </a:xfrm>
           <a:prstGeom prst="rect">
             <a:avLst/>
@@ -5306,18 +5283,18 @@
           <a:p>
             <a:pPr algn="ctr">
               <a:lnSpc>
-                <a:spcPts val="15000"/>
+                <a:spcPts val="14880"/>
               </a:lnSpc>
             </a:pPr>
             <a:r>
-              <a:rPr lang="en-US" sz="12500">
+              <a:rPr lang="en-US" sz="12400">
                 <a:solidFill>
                   <a:srgbClr val="000000"/>
                 </a:solidFill>
-                <a:latin typeface="Jua"/>
-                <a:ea typeface="Jua"/>
-                <a:cs typeface="Jua"/>
-                <a:sym typeface="Jua"/>
+                <a:latin typeface="무궁화 고딕 Bold"/>
+                <a:ea typeface="무궁화 고딕 Bold"/>
+                <a:cs typeface="무궁화 고딕 Bold"/>
+                <a:sym typeface="무궁화 고딕 Bold"/>
               </a:rPr>
               <a:t>3명을 합해 12를 만드세요</a:t>
             </a:r>
@@ -5414,8 +5391,8 @@
         </p:nvSpPr>
         <p:spPr>
           <a:xfrm rot="0">
-            <a:off x="1108788" y="3895725"/>
-            <a:ext cx="16070423" cy="2200275"/>
+            <a:off x="1108788" y="4181475"/>
+            <a:ext cx="16070423" cy="1914525"/>
           </a:xfrm>
           <a:prstGeom prst="rect">
             <a:avLst/>
@@ -5437,10 +5414,10 @@
                 <a:solidFill>
                   <a:srgbClr val="000000"/>
                 </a:solidFill>
-                <a:latin typeface="Jua"/>
-                <a:ea typeface="Jua"/>
-                <a:cs typeface="Jua"/>
-                <a:sym typeface="Jua"/>
+                <a:latin typeface="무궁화 고딕 Bold"/>
+                <a:ea typeface="무궁화 고딕 Bold"/>
+                <a:cs typeface="무궁화 고딕 Bold"/>
+                <a:sym typeface="무궁화 고딕 Bold"/>
               </a:rPr>
               <a:t>3명을 합해 15를 만드세요</a:t>
             </a:r>
@@ -5537,8 +5514,8 @@
         </p:nvSpPr>
         <p:spPr>
           <a:xfrm rot="0">
-            <a:off x="1108788" y="3895725"/>
-            <a:ext cx="16070423" cy="2200275"/>
+            <a:off x="1108788" y="4181475"/>
+            <a:ext cx="16070423" cy="1914525"/>
           </a:xfrm>
           <a:prstGeom prst="rect">
             <a:avLst/>
@@ -5560,10 +5537,10 @@
                 <a:solidFill>
                   <a:srgbClr val="000000"/>
                 </a:solidFill>
-                <a:latin typeface="Jua"/>
-                <a:ea typeface="Jua"/>
-                <a:cs typeface="Jua"/>
-                <a:sym typeface="Jua"/>
+                <a:latin typeface="무궁화 고딕 Bold"/>
+                <a:ea typeface="무궁화 고딕 Bold"/>
+                <a:cs typeface="무궁화 고딕 Bold"/>
+                <a:sym typeface="무궁화 고딕 Bold"/>
               </a:rPr>
               <a:t>1명을 합해 7을 만드세요</a:t>
             </a:r>

</xml_diff>